<commit_message>
Support presentation corrigé et propre
</commit_message>
<xml_diff>
--- a/support-presentation-complet.pptx
+++ b/support-presentation-complet.pptx
@@ -4,6 +4,9 @@
   <p:sldMasterIdLst>
     <p:sldMasterId id="2147483648" r:id="rId1"/>
   </p:sldMasterIdLst>
+  <p:notesMasterIdLst>
+    <p:notesMasterId r:id="rId16"/>
+  </p:notesMasterIdLst>
   <p:sldIdLst>
     <p:sldId id="256" r:id="rId2"/>
     <p:sldId id="257" r:id="rId3"/>
@@ -13,16 +16,13 @@
     <p:sldId id="261" r:id="rId7"/>
     <p:sldId id="262" r:id="rId8"/>
     <p:sldId id="263" r:id="rId9"/>
-    <p:sldId id="264" r:id="rId15"/>
-    <p:sldId id="265" r:id="rId16"/>
-    <p:sldId id="266" r:id="rId17"/>
-    <p:sldId id="267" r:id="rId18"/>
-    <p:sldId id="268" r:id="rId19"/>
-    <p:sldId id="269" r:id="rId20"/>
+    <p:sldId id="264" r:id="rId10"/>
+    <p:sldId id="265" r:id="rId11"/>
+    <p:sldId id="266" r:id="rId12"/>
+    <p:sldId id="267" r:id="rId13"/>
+    <p:sldId id="268" r:id="rId14"/>
+    <p:sldId id="269" r:id="rId15"/>
   </p:sldIdLst>
-  <p:notesMasterIdLst>
-    <p:notesMasterId r:id="rId10"/>
-  </p:notesMasterIdLst>
   <p:sldSz cx="12192000" cy="6858000"/>
   <p:notesSz cx="6858000" cy="12192000"/>
   <p:defaultTextStyle>
@@ -117,7 +117,20 @@
       </a:defRPr>
     </a:lvl9pPr>
   </p:defaultTextStyle>
+  <p:extLst>
+    <p:ext uri="{EFAFB233-063F-42B5-8137-9DF3F51BA10A}">
+      <p15:sldGuideLst xmlns:p15="http://schemas.microsoft.com/office/powerpoint/2012/main"/>
+    </p:ext>
+  </p:extLst>
 </p:presentation>
+</file>
+
+<file path=ppt/revisionInfo.xml><?xml version="1.0" encoding="utf-8"?>
+<p1510:revInfo xmlns:a="http://schemas.openxmlformats.org/drawingml/2006/main" xmlns:r="http://schemas.openxmlformats.org/officeDocument/2006/relationships" xmlns:p1510="http://schemas.microsoft.com/office/powerpoint/2015/10/main">
+  <p1510:revLst>
+    <p1510:client id="{A8DEA2F7-6AA8-41E8-9EB4-A0EF862267A6}" v="1" dt="2026-03-27T14:38:51.805"/>
+  </p1510:revLst>
+</p1510:revInfo>
 </file>
 
 <file path=ppt/notesMasters/notesMaster1.xml><?xml version="1.0" encoding="utf-8"?>
@@ -142,234 +155,10 @@
           <a:chExt cx="0" cy="0"/>
         </a:xfrm>
       </p:grpSpPr>
-      <p:sp>
-        <p:nvSpPr>
-          <p:cNvPr id="2" name="Header Placeholder 1"/>
-          <p:cNvSpPr>
-            <a:spLocks noGrp="1"/>
-          </p:cNvSpPr>
-          <p:nvPr>
-            <p:ph type="hdr" sz="quarter"/>
-          </p:nvPr>
-        </p:nvSpPr>
-        <p:spPr>
-          <a:xfrm>
-            <a:off x="0" y="0"/>
-            <a:ext cx="2971800" cy="458788"/>
-          </a:xfrm>
-          <a:prstGeom prst="rect">
-            <a:avLst/>
-          </a:prstGeom>
-        </p:spPr>
-        <p:txBody>
-          <a:bodyPr vert="horz" lIns="91440" tIns="45720" rIns="91440" bIns="45720" rtlCol="0"/>
-          <a:lstStyle>
-            <a:lvl1pPr algn="l">
-              <a:defRPr sz="1200"/>
-            </a:lvl1pPr>
-          </a:lstStyle>
-          <a:p>
-            <a:endParaRPr lang="en-US"/>
-          </a:p>
-        </p:txBody>
-      </p:sp>
-      <p:sp>
-        <p:nvSpPr>
-          <p:cNvPr id="3" name="Date Placeholder 2"/>
-          <p:cNvSpPr>
-            <a:spLocks noGrp="1"/>
-          </p:cNvSpPr>
-          <p:nvPr>
-            <p:ph type="dt" idx="1"/>
-          </p:nvPr>
-        </p:nvSpPr>
-        <p:spPr>
-          <a:xfrm>
-            <a:off x="3884613" y="0"/>
-            <a:ext cx="2971800" cy="458788"/>
-          </a:xfrm>
-          <a:prstGeom prst="rect">
-            <a:avLst/>
-          </a:prstGeom>
-        </p:spPr>
-        <p:txBody>
-          <a:bodyPr vert="horz" lIns="91440" tIns="45720" rIns="91440" bIns="45720" rtlCol="0"/>
-          <a:lstStyle>
-            <a:lvl1pPr algn="r">
-              <a:defRPr sz="1200"/>
-            </a:lvl1pPr>
-          </a:lstStyle>
-          <a:p>
-            <a:fld id="{5282F153-3F37-0F45-9E97-73ACFA13230C}" type="datetimeFigureOut">
-              <a:rPr lang="en-US"/>
-              <a:t>7/23/19</a:t>
-            </a:fld>
-            <a:endParaRPr lang="en-US"/>
-          </a:p>
-        </p:txBody>
-      </p:sp>
-      <p:sp>
-        <p:nvSpPr>
-          <p:cNvPr id="4" name="Slide Image Placeholder 3"/>
-          <p:cNvSpPr>
-            <a:spLocks noGrp="1" noRot="1" noChangeAspect="1"/>
-          </p:cNvSpPr>
-          <p:nvPr>
-            <p:ph type="sldImg" idx="2"/>
-          </p:nvPr>
-        </p:nvSpPr>
-        <p:spPr>
-          <a:xfrm>
-            <a:off x="685800" y="1143000"/>
-            <a:ext cx="5486400" cy="3086100"/>
-          </a:xfrm>
-          <a:prstGeom prst="rect">
-            <a:avLst/>
-          </a:prstGeom>
-          <a:noFill/>
-          <a:ln w="12700">
-            <a:solidFill>
-              <a:prstClr val="black"/>
-            </a:solidFill>
-          </a:ln>
-        </p:spPr>
-        <p:txBody>
-          <a:bodyPr vert="horz" lIns="91440" tIns="45720" rIns="91440" bIns="45720" rtlCol="0" anchor="ctr"/>
-          <a:lstStyle/>
-          <a:p>
-            <a:endParaRPr lang="en-US"/>
-          </a:p>
-        </p:txBody>
-      </p:sp>
-      <p:sp>
-        <p:nvSpPr>
-          <p:cNvPr id="5" name="Notes Placeholder 4"/>
-          <p:cNvSpPr>
-            <a:spLocks noGrp="1"/>
-          </p:cNvSpPr>
-          <p:nvPr>
-            <p:ph type="body" sz="quarter" idx="3"/>
-          </p:nvPr>
-        </p:nvSpPr>
-        <p:spPr>
-          <a:xfrm>
-            <a:off x="685800" y="4400550"/>
-            <a:ext cx="5486400" cy="3600450"/>
-          </a:xfrm>
-          <a:prstGeom prst="rect">
-            <a:avLst/>
-          </a:prstGeom>
-        </p:spPr>
-        <p:txBody>
-          <a:bodyPr vert="horz" lIns="91440" tIns="45720" rIns="91440" bIns="45720" rtlCol="0"/>
-          <a:lstStyle/>
-          <a:p>
-            <a:pPr lvl="0"/>
-            <a:r>
-              <a:rPr lang="en-US"/>
-              <a:t>Click to edit Master text styles</a:t>
-            </a:r>
-          </a:p>
-          <a:p>
-            <a:pPr lvl="1"/>
-            <a:r>
-              <a:rPr lang="en-US"/>
-              <a:t>Second level</a:t>
-            </a:r>
-          </a:p>
-          <a:p>
-            <a:pPr lvl="2"/>
-            <a:r>
-              <a:rPr lang="en-US"/>
-              <a:t>Third level</a:t>
-            </a:r>
-          </a:p>
-          <a:p>
-            <a:pPr lvl="3"/>
-            <a:r>
-              <a:rPr lang="en-US"/>
-              <a:t>Fourth level</a:t>
-            </a:r>
-          </a:p>
-          <a:p>
-            <a:pPr lvl="4"/>
-            <a:r>
-              <a:rPr lang="en-US"/>
-              <a:t>Fifth level</a:t>
-            </a:r>
-          </a:p>
-        </p:txBody>
-      </p:sp>
-      <p:sp>
-        <p:nvSpPr>
-          <p:cNvPr id="6" name="Footer Placeholder 5"/>
-          <p:cNvSpPr>
-            <a:spLocks noGrp="1"/>
-          </p:cNvSpPr>
-          <p:nvPr>
-            <p:ph type="ftr" sz="quarter" idx="4"/>
-          </p:nvPr>
-        </p:nvSpPr>
-        <p:spPr>
-          <a:xfrm>
-            <a:off x="0" y="8685213"/>
-            <a:ext cx="2971800" cy="458787"/>
-          </a:xfrm>
-          <a:prstGeom prst="rect">
-            <a:avLst/>
-          </a:prstGeom>
-        </p:spPr>
-        <p:txBody>
-          <a:bodyPr vert="horz" lIns="91440" tIns="45720" rIns="91440" bIns="45720" rtlCol="0" anchor="b"/>
-          <a:lstStyle>
-            <a:lvl1pPr algn="l">
-              <a:defRPr sz="1200"/>
-            </a:lvl1pPr>
-          </a:lstStyle>
-          <a:p>
-            <a:endParaRPr lang="en-US"/>
-          </a:p>
-        </p:txBody>
-      </p:sp>
-      <p:sp>
-        <p:nvSpPr>
-          <p:cNvPr id="7" name="Slide Number Placeholder 6"/>
-          <p:cNvSpPr>
-            <a:spLocks noGrp="1"/>
-          </p:cNvSpPr>
-          <p:nvPr>
-            <p:ph type="sldNum" sz="quarter" idx="5"/>
-          </p:nvPr>
-        </p:nvSpPr>
-        <p:spPr>
-          <a:xfrm>
-            <a:off x="3884613" y="8685213"/>
-            <a:ext cx="2971800" cy="458787"/>
-          </a:xfrm>
-          <a:prstGeom prst="rect">
-            <a:avLst/>
-          </a:prstGeom>
-        </p:spPr>
-        <p:txBody>
-          <a:bodyPr vert="horz" lIns="91440" tIns="45720" rIns="91440" bIns="45720" rtlCol="0" anchor="b"/>
-          <a:lstStyle>
-            <a:lvl1pPr algn="r">
-              <a:defRPr sz="1200"/>
-            </a:lvl1pPr>
-          </a:lstStyle>
-          <a:p>
-            <a:fld id="{CE5E9CC1-C706-0F49-92D6-E571CC5EEA8F}" type="slidenum">
-              <a:rPr lang="en-US"/>
-              <a:t>‹#›</a:t>
-            </a:fld>
-            <a:endParaRPr lang="en-US"/>
-          </a:p>
-        </p:txBody>
-      </p:sp>
     </p:spTree>
     <p:extLst>
       <p:ext uri="{BB962C8B-B14F-4D97-AF65-F5344CB8AC3E}">
-        <p14:creationId xmlns:p14="http://schemas.microsoft.com/office/powerpoint/2010/main" val="1024086991"/>
+        <p14:creationId xmlns:p14="http://schemas.microsoft.com/office/powerpoint/2010/main" val="3835662532"/>
       </p:ext>
     </p:extLst>
   </p:cSld>
@@ -513,10 +302,6 @@
           <a:bodyPr/>
           <a:lstStyle/>
           <a:p>
-            <a:r>
-              <a:rPr lang="en-US" dirty="0"/>
-              <a:t/>
-            </a:r>
             <a:endParaRPr lang="en-US" dirty="0"/>
           </a:p>
         </p:txBody>
@@ -601,10 +386,6 @@
           <a:bodyPr/>
           <a:lstStyle/>
           <a:p>
-            <a:r>
-              <a:rPr lang="en-US" dirty="0"/>
-              <a:t/>
-            </a:r>
             <a:endParaRPr lang="en-US" dirty="0"/>
           </a:p>
         </p:txBody>
@@ -689,10 +470,6 @@
           <a:bodyPr/>
           <a:lstStyle/>
           <a:p>
-            <a:r>
-              <a:rPr lang="en-US" dirty="0"/>
-              <a:t/>
-            </a:r>
             <a:endParaRPr lang="en-US" dirty="0"/>
           </a:p>
         </p:txBody>
@@ -777,10 +554,6 @@
           <a:bodyPr/>
           <a:lstStyle/>
           <a:p>
-            <a:r>
-              <a:rPr lang="en-US" dirty="0"/>
-              <a:t/>
-            </a:r>
             <a:endParaRPr lang="en-US" dirty="0"/>
           </a:p>
         </p:txBody>
@@ -865,10 +638,6 @@
           <a:bodyPr/>
           <a:lstStyle/>
           <a:p>
-            <a:r>
-              <a:rPr lang="en-US" dirty="0"/>
-              <a:t/>
-            </a:r>
             <a:endParaRPr lang="en-US" dirty="0"/>
           </a:p>
         </p:txBody>
@@ -953,10 +722,6 @@
           <a:bodyPr/>
           <a:lstStyle/>
           <a:p>
-            <a:r>
-              <a:rPr lang="en-US" dirty="0"/>
-              <a:t/>
-            </a:r>
             <a:endParaRPr lang="en-US" dirty="0"/>
           </a:p>
         </p:txBody>
@@ -1041,10 +806,6 @@
           <a:bodyPr/>
           <a:lstStyle/>
           <a:p>
-            <a:r>
-              <a:rPr lang="en-US" dirty="0"/>
-              <a:t/>
-            </a:r>
             <a:endParaRPr lang="en-US" dirty="0"/>
           </a:p>
         </p:txBody>
@@ -1129,10 +890,6 @@
           <a:bodyPr/>
           <a:lstStyle/>
           <a:p>
-            <a:r>
-              <a:rPr lang="en-US" dirty="0"/>
-              <a:t/>
-            </a:r>
             <a:endParaRPr lang="en-US" dirty="0"/>
           </a:p>
         </p:txBody>
@@ -1206,6 +963,11 @@
 <file path=ppt/slideMasters/slideMaster1.xml><?xml version="1.0" encoding="utf-8"?>
 <p:sldMaster xmlns:a="http://schemas.openxmlformats.org/drawingml/2006/main" xmlns:r="http://schemas.openxmlformats.org/officeDocument/2006/relationships" xmlns:p="http://schemas.openxmlformats.org/presentationml/2006/main">
   <p:cSld>
+    <p:bg>
+      <p:bgRef idx="1001">
+        <a:schemeClr val="bg1"/>
+      </p:bgRef>
+    </p:bg>
     <p:spTree>
       <p:nvGrpSpPr>
         <p:cNvPr id="1" name=""/>
@@ -1488,6 +1250,7 @@
         <a:solidFill>
           <a:srgbClr val="F8FAFC"/>
         </a:solidFill>
+        <a:effectLst/>
       </p:bgPr>
     </p:bg>
     <p:spTree>
@@ -1555,7 +1318,7 @@
             <a:prstDash val="solid"/>
           </a:ln>
           <a:effectLst>
-            <a:outerShdw sx="100000" sy="100000" kx="0" ky="0" algn="bl" rotWithShape="0" blurRad="19050" dist="12700" dir="2700000">
+            <a:outerShdw blurRad="19050" dist="12700" dir="2700000" algn="bl" rotWithShape="0">
               <a:srgbClr val="000000">
                 <a:alpha val="14000"/>
               </a:srgbClr>
@@ -1609,7 +1372,7 @@
           <a:bodyPr wrap="square" rtlCol="0" anchor="ctr"/>
           <a:lstStyle/>
           <a:p>
-            <a:pPr indent="0" marL="0">
+            <a:pPr marL="0" indent="0">
               <a:buNone/>
             </a:pPr>
             <a:r>
@@ -1626,7 +1389,7 @@
             <a:endParaRPr lang="en-US" sz="2400" dirty="0"/>
           </a:p>
           <a:p>
-            <a:pPr indent="0" marL="0">
+            <a:pPr marL="0" indent="0">
               <a:buNone/>
             </a:pPr>
             <a:r>
@@ -1665,7 +1428,7 @@
           <a:bodyPr wrap="square" rtlCol="0" anchor="ctr"/>
           <a:lstStyle/>
           <a:p>
-            <a:pPr indent="0" marL="0">
+            <a:pPr marL="0" indent="0">
               <a:buNone/>
             </a:pPr>
             <a:r>
@@ -1701,7 +1464,7 @@
           <a:bodyPr wrap="square" rtlCol="0" anchor="ctr"/>
           <a:lstStyle/>
           <a:p>
-            <a:pPr indent="0" marL="0">
+            <a:pPr marL="0" indent="0">
               <a:buNone/>
             </a:pPr>
             <a:r>
@@ -1737,7 +1500,7 @@
           <a:bodyPr wrap="square" rtlCol="0" anchor="ctr"/>
           <a:lstStyle/>
           <a:p>
-            <a:pPr indent="0" marL="0">
+            <a:pPr marL="0" indent="0">
               <a:buNone/>
             </a:pPr>
             <a:r>
@@ -1800,7 +1563,7 @@
           <a:bodyPr wrap="square" rtlCol="0" anchor="ctr"/>
           <a:lstStyle/>
           <a:p>
-            <a:pPr algn="ctr" indent="0" marL="0">
+            <a:pPr marL="0" indent="0" algn="ctr">
               <a:buNone/>
             </a:pPr>
             <a:r>
@@ -1863,7 +1626,7 @@
           <a:bodyPr wrap="square" rtlCol="0" anchor="ctr"/>
           <a:lstStyle/>
           <a:p>
-            <a:pPr algn="ctr" indent="0" marL="0">
+            <a:pPr marL="0" indent="0" algn="ctr">
               <a:buNone/>
             </a:pPr>
             <a:r>
@@ -1926,7 +1689,7 @@
           <a:bodyPr wrap="square" rtlCol="0" anchor="ctr"/>
           <a:lstStyle/>
           <a:p>
-            <a:pPr algn="ctr" indent="0" marL="0">
+            <a:pPr marL="0" indent="0" algn="ctr">
               <a:buNone/>
             </a:pPr>
             <a:r>
@@ -1962,7 +1725,7 @@
           <a:bodyPr wrap="square" rtlCol="0" anchor="ctr"/>
           <a:lstStyle/>
           <a:p>
-            <a:pPr algn="r" indent="0" marL="0">
+            <a:pPr marL="0" indent="0" algn="r">
               <a:buNone/>
             </a:pPr>
             <a:r>
@@ -1986,7 +1749,7 @@
 </file>
 
 <file path=ppt/slides/slide10.xml><?xml version="1.0" encoding="utf-8"?>
-<p:sld xmlns:a="http://schemas.openxmlformats.org/drawingml/2006/main" xmlns:p="http://schemas.openxmlformats.org/presentationml/2006/main" xmlns:r="http://schemas.openxmlformats.org/officeDocument/2006/relationships">
+<p:sld xmlns:a="http://schemas.openxmlformats.org/drawingml/2006/main" xmlns:r="http://schemas.openxmlformats.org/officeDocument/2006/relationships" xmlns:p="http://schemas.openxmlformats.org/presentationml/2006/main">
   <p:cSld>
     <p:spTree>
       <p:nvGrpSpPr>
@@ -1994,7 +1757,14 @@
         <p:cNvGrpSpPr/>
         <p:nvPr/>
       </p:nvGrpSpPr>
-      <p:grpSpPr/>
+      <p:grpSpPr>
+        <a:xfrm>
+          <a:off x="0" y="0"/>
+          <a:ext cx="0" cy="0"/>
+          <a:chOff x="0" y="0"/>
+          <a:chExt cx="0" cy="0"/>
+        </a:xfrm>
+      </p:grpSpPr>
       <p:sp>
         <p:nvSpPr>
           <p:cNvPr id="2" name="TextBox 1"/>
@@ -2084,7 +1854,7 @@
 </file>
 
 <file path=ppt/slides/slide11.xml><?xml version="1.0" encoding="utf-8"?>
-<p:sld xmlns:a="http://schemas.openxmlformats.org/drawingml/2006/main" xmlns:p="http://schemas.openxmlformats.org/presentationml/2006/main" xmlns:r="http://schemas.openxmlformats.org/officeDocument/2006/relationships">
+<p:sld xmlns:a="http://schemas.openxmlformats.org/drawingml/2006/main" xmlns:r="http://schemas.openxmlformats.org/officeDocument/2006/relationships" xmlns:p="http://schemas.openxmlformats.org/presentationml/2006/main">
   <p:cSld>
     <p:spTree>
       <p:nvGrpSpPr>
@@ -2092,7 +1862,14 @@
         <p:cNvGrpSpPr/>
         <p:nvPr/>
       </p:nvGrpSpPr>
-      <p:grpSpPr/>
+      <p:grpSpPr>
+        <a:xfrm>
+          <a:off x="0" y="0"/>
+          <a:ext cx="0" cy="0"/>
+          <a:chOff x="0" y="0"/>
+          <a:chExt cx="0" cy="0"/>
+        </a:xfrm>
+      </p:grpSpPr>
       <p:sp>
         <p:nvSpPr>
           <p:cNvPr id="2" name="TextBox 1"/>
@@ -2182,7 +1959,7 @@
 </file>
 
 <file path=ppt/slides/slide12.xml><?xml version="1.0" encoding="utf-8"?>
-<p:sld xmlns:a="http://schemas.openxmlformats.org/drawingml/2006/main" xmlns:p="http://schemas.openxmlformats.org/presentationml/2006/main" xmlns:r="http://schemas.openxmlformats.org/officeDocument/2006/relationships">
+<p:sld xmlns:a="http://schemas.openxmlformats.org/drawingml/2006/main" xmlns:r="http://schemas.openxmlformats.org/officeDocument/2006/relationships" xmlns:p="http://schemas.openxmlformats.org/presentationml/2006/main">
   <p:cSld>
     <p:spTree>
       <p:nvGrpSpPr>
@@ -2190,7 +1967,14 @@
         <p:cNvGrpSpPr/>
         <p:nvPr/>
       </p:nvGrpSpPr>
-      <p:grpSpPr/>
+      <p:grpSpPr>
+        <a:xfrm>
+          <a:off x="0" y="0"/>
+          <a:ext cx="0" cy="0"/>
+          <a:chOff x="0" y="0"/>
+          <a:chExt cx="0" cy="0"/>
+        </a:xfrm>
+      </p:grpSpPr>
       <p:sp>
         <p:nvSpPr>
           <p:cNvPr id="2" name="TextBox 1"/>
@@ -2280,7 +2064,7 @@
 </file>
 
 <file path=ppt/slides/slide13.xml><?xml version="1.0" encoding="utf-8"?>
-<p:sld xmlns:a="http://schemas.openxmlformats.org/drawingml/2006/main" xmlns:p="http://schemas.openxmlformats.org/presentationml/2006/main" xmlns:r="http://schemas.openxmlformats.org/officeDocument/2006/relationships">
+<p:sld xmlns:a="http://schemas.openxmlformats.org/drawingml/2006/main" xmlns:r="http://schemas.openxmlformats.org/officeDocument/2006/relationships" xmlns:p="http://schemas.openxmlformats.org/presentationml/2006/main">
   <p:cSld>
     <p:spTree>
       <p:nvGrpSpPr>
@@ -2288,7 +2072,14 @@
         <p:cNvGrpSpPr/>
         <p:nvPr/>
       </p:nvGrpSpPr>
-      <p:grpSpPr/>
+      <p:grpSpPr>
+        <a:xfrm>
+          <a:off x="0" y="0"/>
+          <a:ext cx="0" cy="0"/>
+          <a:chOff x="0" y="0"/>
+          <a:chExt cx="0" cy="0"/>
+        </a:xfrm>
+      </p:grpSpPr>
       <p:sp>
         <p:nvSpPr>
           <p:cNvPr id="2" name="TextBox 1"/>
@@ -2378,7 +2169,7 @@
 </file>
 
 <file path=ppt/slides/slide14.xml><?xml version="1.0" encoding="utf-8"?>
-<p:sld xmlns:a="http://schemas.openxmlformats.org/drawingml/2006/main" xmlns:p="http://schemas.openxmlformats.org/presentationml/2006/main" xmlns:r="http://schemas.openxmlformats.org/officeDocument/2006/relationships">
+<p:sld xmlns:a="http://schemas.openxmlformats.org/drawingml/2006/main" xmlns:r="http://schemas.openxmlformats.org/officeDocument/2006/relationships" xmlns:p="http://schemas.openxmlformats.org/presentationml/2006/main">
   <p:cSld>
     <p:spTree>
       <p:nvGrpSpPr>
@@ -2386,7 +2177,14 @@
         <p:cNvGrpSpPr/>
         <p:nvPr/>
       </p:nvGrpSpPr>
-      <p:grpSpPr/>
+      <p:grpSpPr>
+        <a:xfrm>
+          <a:off x="0" y="0"/>
+          <a:ext cx="0" cy="0"/>
+          <a:chOff x="0" y="0"/>
+          <a:chExt cx="0" cy="0"/>
+        </a:xfrm>
+      </p:grpSpPr>
       <p:sp>
         <p:nvSpPr>
           <p:cNvPr id="2" name="TextBox 1"/>
@@ -2483,6 +2281,7 @@
         <a:solidFill>
           <a:srgbClr val="F8FAFC"/>
         </a:solidFill>
+        <a:effectLst/>
       </p:bgPr>
     </p:bg>
     <p:spTree>
@@ -2545,7 +2344,7 @@
           <a:bodyPr wrap="square" rtlCol="0" anchor="ctr"/>
           <a:lstStyle/>
           <a:p>
-            <a:pPr indent="0" marL="0">
+            <a:pPr marL="0" indent="0">
               <a:buNone/>
             </a:pPr>
             <a:r>
@@ -2584,7 +2383,7 @@
           <a:bodyPr wrap="square" rtlCol="0" anchor="ctr"/>
           <a:lstStyle/>
           <a:p>
-            <a:pPr indent="0" marL="0">
+            <a:pPr marL="0" indent="0">
               <a:buNone/>
             </a:pPr>
             <a:r>
@@ -2689,7 +2488,7 @@
         </p:nvSpPr>
         <p:spPr>
           <a:xfrm>
-            <a:off x="6583680" y="1645920"/>
+            <a:off x="6517097" y="1904852"/>
             <a:ext cx="4800600" cy="3429000"/>
           </a:xfrm>
           <a:prstGeom prst="roundRect">
@@ -2729,7 +2528,7 @@
           <a:bodyPr wrap="square" rtlCol="0" anchor="ctr"/>
           <a:lstStyle/>
           <a:p>
-            <a:pPr indent="0" marL="0">
+            <a:pPr marL="0" indent="0">
               <a:buNone/>
             </a:pPr>
             <a:r>
@@ -2847,7 +2646,7 @@
           <a:bodyPr wrap="square" rtlCol="0" anchor="ctr"/>
           <a:lstStyle/>
           <a:p>
-            <a:pPr indent="0" marL="0">
+            <a:pPr marL="0" indent="0">
               <a:buNone/>
             </a:pPr>
             <a:r>
@@ -2883,7 +2682,7 @@
           <a:bodyPr wrap="square" rtlCol="0" anchor="ctr"/>
           <a:lstStyle/>
           <a:p>
-            <a:pPr algn="r" indent="0" marL="0">
+            <a:pPr marL="0" indent="0" algn="r">
               <a:buNone/>
             </a:pPr>
             <a:r>
@@ -2914,6 +2713,7 @@
         <a:solidFill>
           <a:srgbClr val="F8FAFC"/>
         </a:solidFill>
+        <a:effectLst/>
       </p:bgPr>
     </p:bg>
     <p:spTree>
@@ -2976,7 +2776,7 @@
           <a:bodyPr wrap="square" rtlCol="0" anchor="ctr"/>
           <a:lstStyle/>
           <a:p>
-            <a:pPr indent="0" marL="0">
+            <a:pPr marL="0" indent="0">
               <a:buNone/>
             </a:pPr>
             <a:r>
@@ -3015,7 +2815,7 @@
           <a:bodyPr wrap="square" rtlCol="0" anchor="ctr"/>
           <a:lstStyle/>
           <a:p>
-            <a:pPr indent="0" marL="0">
+            <a:pPr marL="0" indent="0">
               <a:buNone/>
             </a:pPr>
             <a:r>
@@ -3078,7 +2878,7 @@
           <a:bodyPr wrap="square" rtlCol="0" anchor="ctr"/>
           <a:lstStyle/>
           <a:p>
-            <a:pPr indent="0" marL="0">
+            <a:pPr marL="0" indent="0">
               <a:buNone/>
             </a:pPr>
             <a:r>
@@ -3114,7 +2914,7 @@
           <a:bodyPr wrap="square" rtlCol="0" anchor="ctr"/>
           <a:lstStyle/>
           <a:p>
-            <a:pPr indent="0" marL="0">
+            <a:pPr marL="0" indent="0">
               <a:buNone/>
             </a:pPr>
             <a:r>
@@ -3177,7 +2977,7 @@
           <a:bodyPr wrap="square" rtlCol="0" anchor="ctr"/>
           <a:lstStyle/>
           <a:p>
-            <a:pPr indent="0" marL="0">
+            <a:pPr marL="0" indent="0">
               <a:buNone/>
             </a:pPr>
             <a:r>
@@ -3213,7 +3013,7 @@
           <a:bodyPr wrap="square" rtlCol="0" anchor="ctr"/>
           <a:lstStyle/>
           <a:p>
-            <a:pPr indent="0" marL="0">
+            <a:pPr marL="0" indent="0">
               <a:buNone/>
             </a:pPr>
             <a:r>
@@ -3276,7 +3076,7 @@
           <a:bodyPr wrap="square" rtlCol="0" anchor="ctr"/>
           <a:lstStyle/>
           <a:p>
-            <a:pPr indent="0" marL="0">
+            <a:pPr marL="0" indent="0">
               <a:buNone/>
             </a:pPr>
             <a:r>
@@ -3312,7 +3112,7 @@
           <a:bodyPr wrap="square" rtlCol="0" anchor="ctr"/>
           <a:lstStyle/>
           <a:p>
-            <a:pPr indent="0" marL="0">
+            <a:pPr marL="0" indent="0">
               <a:buNone/>
             </a:pPr>
             <a:r>
@@ -3375,7 +3175,7 @@
           <a:bodyPr wrap="square" rtlCol="0" anchor="ctr"/>
           <a:lstStyle/>
           <a:p>
-            <a:pPr indent="0" marL="0">
+            <a:pPr marL="0" indent="0">
               <a:buNone/>
             </a:pPr>
             <a:r>
@@ -3411,7 +3211,7 @@
           <a:bodyPr wrap="square" rtlCol="0" anchor="ctr"/>
           <a:lstStyle/>
           <a:p>
-            <a:pPr indent="0" marL="0">
+            <a:pPr marL="0" indent="0">
               <a:buNone/>
             </a:pPr>
             <a:r>
@@ -3447,7 +3247,7 @@
           <a:bodyPr wrap="square" rtlCol="0" anchor="ctr"/>
           <a:lstStyle/>
           <a:p>
-            <a:pPr algn="ctr" indent="0" marL="0">
+            <a:pPr marL="0" indent="0" algn="ctr">
               <a:buNone/>
             </a:pPr>
             <a:r>
@@ -3483,7 +3283,7 @@
           <a:bodyPr wrap="square" rtlCol="0" anchor="ctr"/>
           <a:lstStyle/>
           <a:p>
-            <a:pPr algn="ctr" indent="0" marL="0">
+            <a:pPr marL="0" indent="0" algn="ctr">
               <a:buNone/>
             </a:pPr>
             <a:r>
@@ -3519,7 +3319,7 @@
           <a:bodyPr wrap="square" rtlCol="0" anchor="ctr"/>
           <a:lstStyle/>
           <a:p>
-            <a:pPr algn="ctr" indent="0" marL="0">
+            <a:pPr marL="0" indent="0" algn="ctr">
               <a:buNone/>
             </a:pPr>
             <a:r>
@@ -3555,7 +3355,7 @@
           <a:bodyPr wrap="square" rtlCol="0" anchor="ctr"/>
           <a:lstStyle/>
           <a:p>
-            <a:pPr algn="ctr" indent="0" marL="0">
+            <a:pPr marL="0" indent="0" algn="ctr">
               <a:buNone/>
             </a:pPr>
             <a:r>
@@ -3591,7 +3391,7 @@
           <a:bodyPr wrap="square" rtlCol="0" anchor="ctr"/>
           <a:lstStyle/>
           <a:p>
-            <a:pPr algn="r" indent="0" marL="0">
+            <a:pPr marL="0" indent="0" algn="r">
               <a:buNone/>
             </a:pPr>
             <a:r>
@@ -3622,6 +3422,7 @@
         <a:solidFill>
           <a:srgbClr val="F8FAFC"/>
         </a:solidFill>
+        <a:effectLst/>
       </p:bgPr>
     </p:bg>
     <p:spTree>
@@ -3684,7 +3485,7 @@
           <a:bodyPr wrap="square" rtlCol="0" anchor="ctr"/>
           <a:lstStyle/>
           <a:p>
-            <a:pPr indent="0" marL="0">
+            <a:pPr marL="0" indent="0">
               <a:buNone/>
             </a:pPr>
             <a:r>
@@ -3723,7 +3524,7 @@
           <a:bodyPr wrap="square" rtlCol="0" anchor="ctr"/>
           <a:lstStyle/>
           <a:p>
-            <a:pPr indent="0" marL="0">
+            <a:pPr marL="0" indent="0">
               <a:buNone/>
             </a:pPr>
             <a:r>
@@ -3786,7 +3587,7 @@
           <a:bodyPr wrap="square" rtlCol="0" anchor="ctr"/>
           <a:lstStyle/>
           <a:p>
-            <a:pPr algn="ctr" indent="0" marL="0">
+            <a:pPr marL="0" indent="0" algn="ctr">
               <a:buNone/>
             </a:pPr>
             <a:r>
@@ -3800,7 +3601,7 @@
             <a:endParaRPr lang="en-US" sz="2000" dirty="0"/>
           </a:p>
           <a:p>
-            <a:pPr algn="ctr" indent="0" marL="0">
+            <a:pPr marL="0" indent="0" algn="ctr">
               <a:buNone/>
             </a:pPr>
             <a:r>
@@ -3863,7 +3664,7 @@
           <a:bodyPr wrap="square" rtlCol="0" anchor="ctr"/>
           <a:lstStyle/>
           <a:p>
-            <a:pPr indent="0" marL="0">
+            <a:pPr marL="0" indent="0">
               <a:buNone/>
             </a:pPr>
             <a:r>
@@ -4008,7 +3809,7 @@
           <a:bodyPr wrap="square" rtlCol="0" anchor="ctr"/>
           <a:lstStyle/>
           <a:p>
-            <a:pPr indent="0" marL="0">
+            <a:pPr marL="0" indent="0">
               <a:buNone/>
             </a:pPr>
             <a:r>
@@ -4126,7 +3927,7 @@
           <a:bodyPr wrap="square" rtlCol="0" anchor="ctr"/>
           <a:lstStyle/>
           <a:p>
-            <a:pPr algn="ctr" indent="0" marL="0">
+            <a:pPr marL="0" indent="0" algn="ctr">
               <a:buNone/>
             </a:pPr>
             <a:r>
@@ -4140,7 +3941,7 @@
             <a:endParaRPr lang="en-US" sz="1600" dirty="0"/>
           </a:p>
           <a:p>
-            <a:pPr algn="ctr" indent="0" marL="0">
+            <a:pPr marL="0" indent="0" algn="ctr">
               <a:buNone/>
             </a:pPr>
             <a:r>
@@ -4154,7 +3955,7 @@
             <a:endParaRPr lang="en-US" sz="1600" dirty="0"/>
           </a:p>
           <a:p>
-            <a:pPr algn="ctr" indent="0" marL="0">
+            <a:pPr marL="0" indent="0" algn="ctr">
               <a:buNone/>
             </a:pPr>
             <a:r>
@@ -4190,7 +3991,7 @@
           <a:bodyPr wrap="square" rtlCol="0" anchor="ctr"/>
           <a:lstStyle/>
           <a:p>
-            <a:pPr algn="ctr" indent="0" marL="0">
+            <a:pPr marL="0" indent="0" algn="ctr">
               <a:buNone/>
             </a:pPr>
             <a:r>
@@ -4204,7 +4005,7 @@
             <a:endParaRPr lang="en-US" sz="1600" dirty="0"/>
           </a:p>
           <a:p>
-            <a:pPr algn="ctr" indent="0" marL="0">
+            <a:pPr marL="0" indent="0" algn="ctr">
               <a:buNone/>
             </a:pPr>
             <a:r>
@@ -4240,7 +4041,7 @@
           <a:bodyPr wrap="square" rtlCol="0" anchor="ctr"/>
           <a:lstStyle/>
           <a:p>
-            <a:pPr algn="r" indent="0" marL="0">
+            <a:pPr marL="0" indent="0" algn="r">
               <a:buNone/>
             </a:pPr>
             <a:r>
@@ -4271,6 +4072,7 @@
         <a:solidFill>
           <a:srgbClr val="F8FAFC"/>
         </a:solidFill>
+        <a:effectLst/>
       </p:bgPr>
     </p:bg>
     <p:spTree>
@@ -4333,7 +4135,7 @@
           <a:bodyPr wrap="square" rtlCol="0" anchor="ctr"/>
           <a:lstStyle/>
           <a:p>
-            <a:pPr indent="0" marL="0">
+            <a:pPr marL="0" indent="0">
               <a:buNone/>
             </a:pPr>
             <a:r>
@@ -4372,7 +4174,7 @@
           <a:bodyPr wrap="square" rtlCol="0" anchor="ctr"/>
           <a:lstStyle/>
           <a:p>
-            <a:pPr indent="0" marL="0">
+            <a:pPr marL="0" indent="0">
               <a:buNone/>
             </a:pPr>
             <a:r>
@@ -4433,7 +4235,7 @@
           <a:bodyPr wrap="square" rtlCol="0" anchor="ctr"/>
           <a:lstStyle/>
           <a:p>
-            <a:pPr algn="ctr" indent="0" marL="0">
+            <a:pPr marL="0" indent="0" algn="ctr">
               <a:buNone/>
             </a:pPr>
             <a:r>
@@ -4469,7 +4271,7 @@
           <a:bodyPr wrap="square" rtlCol="0" anchor="ctr"/>
           <a:lstStyle/>
           <a:p>
-            <a:pPr indent="0" marL="0">
+            <a:pPr marL="0" indent="0">
               <a:buNone/>
             </a:pPr>
             <a:r>
@@ -4505,7 +4307,7 @@
           <a:bodyPr wrap="square" rtlCol="0" anchor="ctr"/>
           <a:lstStyle/>
           <a:p>
-            <a:pPr indent="0" marL="0">
+            <a:pPr marL="0" indent="0">
               <a:buNone/>
             </a:pPr>
             <a:r>
@@ -4566,7 +4368,7 @@
           <a:bodyPr wrap="square" rtlCol="0" anchor="ctr"/>
           <a:lstStyle/>
           <a:p>
-            <a:pPr algn="ctr" indent="0" marL="0">
+            <a:pPr marL="0" indent="0" algn="ctr">
               <a:buNone/>
             </a:pPr>
             <a:r>
@@ -4602,7 +4404,7 @@
           <a:bodyPr wrap="square" rtlCol="0" anchor="ctr"/>
           <a:lstStyle/>
           <a:p>
-            <a:pPr indent="0" marL="0">
+            <a:pPr marL="0" indent="0">
               <a:buNone/>
             </a:pPr>
             <a:r>
@@ -4638,7 +4440,7 @@
           <a:bodyPr wrap="square" rtlCol="0" anchor="ctr"/>
           <a:lstStyle/>
           <a:p>
-            <a:pPr indent="0" marL="0">
+            <a:pPr marL="0" indent="0">
               <a:buNone/>
             </a:pPr>
             <a:r>
@@ -4699,7 +4501,7 @@
           <a:bodyPr wrap="square" rtlCol="0" anchor="ctr"/>
           <a:lstStyle/>
           <a:p>
-            <a:pPr algn="ctr" indent="0" marL="0">
+            <a:pPr marL="0" indent="0" algn="ctr">
               <a:buNone/>
             </a:pPr>
             <a:r>
@@ -4735,7 +4537,7 @@
           <a:bodyPr wrap="square" rtlCol="0" anchor="ctr"/>
           <a:lstStyle/>
           <a:p>
-            <a:pPr indent="0" marL="0">
+            <a:pPr marL="0" indent="0">
               <a:buNone/>
             </a:pPr>
             <a:r>
@@ -4771,7 +4573,7 @@
           <a:bodyPr wrap="square" rtlCol="0" anchor="ctr"/>
           <a:lstStyle/>
           <a:p>
-            <a:pPr indent="0" marL="0">
+            <a:pPr marL="0" indent="0">
               <a:buNone/>
             </a:pPr>
             <a:r>
@@ -4832,7 +4634,7 @@
           <a:bodyPr wrap="square" rtlCol="0" anchor="ctr"/>
           <a:lstStyle/>
           <a:p>
-            <a:pPr algn="ctr" indent="0" marL="0">
+            <a:pPr marL="0" indent="0" algn="ctr">
               <a:buNone/>
             </a:pPr>
             <a:r>
@@ -4868,7 +4670,7 @@
           <a:bodyPr wrap="square" rtlCol="0" anchor="ctr"/>
           <a:lstStyle/>
           <a:p>
-            <a:pPr indent="0" marL="0">
+            <a:pPr marL="0" indent="0">
               <a:buNone/>
             </a:pPr>
             <a:r>
@@ -4904,7 +4706,7 @@
           <a:bodyPr wrap="square" rtlCol="0" anchor="ctr"/>
           <a:lstStyle/>
           <a:p>
-            <a:pPr indent="0" marL="0">
+            <a:pPr marL="0" indent="0">
               <a:buNone/>
             </a:pPr>
             <a:r>
@@ -4965,7 +4767,7 @@
           <a:bodyPr wrap="square" rtlCol="0" anchor="ctr"/>
           <a:lstStyle/>
           <a:p>
-            <a:pPr algn="ctr" indent="0" marL="0">
+            <a:pPr marL="0" indent="0" algn="ctr">
               <a:buNone/>
             </a:pPr>
             <a:r>
@@ -5001,7 +4803,7 @@
           <a:bodyPr wrap="square" rtlCol="0" anchor="ctr"/>
           <a:lstStyle/>
           <a:p>
-            <a:pPr indent="0" marL="0">
+            <a:pPr marL="0" indent="0">
               <a:buNone/>
             </a:pPr>
             <a:r>
@@ -5037,7 +4839,7 @@
           <a:bodyPr wrap="square" rtlCol="0" anchor="ctr"/>
           <a:lstStyle/>
           <a:p>
-            <a:pPr indent="0" marL="0">
+            <a:pPr marL="0" indent="0">
               <a:buNone/>
             </a:pPr>
             <a:r>
@@ -5073,7 +4875,7 @@
           <a:bodyPr wrap="square" rtlCol="0" anchor="ctr"/>
           <a:lstStyle/>
           <a:p>
-            <a:pPr algn="r" indent="0" marL="0">
+            <a:pPr marL="0" indent="0" algn="r">
               <a:buNone/>
             </a:pPr>
             <a:r>
@@ -5104,6 +4906,7 @@
         <a:solidFill>
           <a:srgbClr val="F8FAFC"/>
         </a:solidFill>
+        <a:effectLst/>
       </p:bgPr>
     </p:bg>
     <p:spTree>
@@ -5166,7 +4969,7 @@
           <a:bodyPr wrap="square" rtlCol="0" anchor="ctr"/>
           <a:lstStyle/>
           <a:p>
-            <a:pPr indent="0" marL="0">
+            <a:pPr marL="0" indent="0">
               <a:buNone/>
             </a:pPr>
             <a:r>
@@ -5205,7 +5008,7 @@
           <a:bodyPr wrap="square" rtlCol="0" anchor="ctr"/>
           <a:lstStyle/>
           <a:p>
-            <a:pPr indent="0" marL="0">
+            <a:pPr marL="0" indent="0">
               <a:buNone/>
             </a:pPr>
             <a:r>
@@ -5295,7 +5098,7 @@
           <a:bodyPr wrap="square" rtlCol="0" anchor="ctr"/>
           <a:lstStyle/>
           <a:p>
-            <a:pPr indent="0" marL="0">
+            <a:pPr marL="0" indent="0">
               <a:buNone/>
             </a:pPr>
             <a:r>
@@ -5398,7 +5201,7 @@
           <a:bodyPr wrap="square" rtlCol="0" anchor="ctr"/>
           <a:lstStyle/>
           <a:p>
-            <a:pPr indent="0" marL="0">
+            <a:pPr marL="0" indent="0">
               <a:buNone/>
             </a:pPr>
             <a:r>
@@ -5501,7 +5304,7 @@
           <a:bodyPr wrap="square" rtlCol="0" anchor="ctr"/>
           <a:lstStyle/>
           <a:p>
-            <a:pPr algn="r" indent="0" marL="0">
+            <a:pPr marL="0" indent="0" algn="r">
               <a:buNone/>
             </a:pPr>
             <a:r>
@@ -5532,6 +5335,7 @@
         <a:solidFill>
           <a:srgbClr val="F8FAFC"/>
         </a:solidFill>
+        <a:effectLst/>
       </p:bgPr>
     </p:bg>
     <p:spTree>
@@ -5594,7 +5398,7 @@
           <a:bodyPr wrap="square" rtlCol="0" anchor="ctr"/>
           <a:lstStyle/>
           <a:p>
-            <a:pPr indent="0" marL="0">
+            <a:pPr marL="0" indent="0">
               <a:buNone/>
             </a:pPr>
             <a:r>
@@ -5633,7 +5437,7 @@
           <a:bodyPr wrap="square" rtlCol="0" anchor="ctr"/>
           <a:lstStyle/>
           <a:p>
-            <a:pPr indent="0" marL="0">
+            <a:pPr marL="0" indent="0">
               <a:buNone/>
             </a:pPr>
             <a:r>
@@ -5696,7 +5500,7 @@
           <a:bodyPr wrap="square" rtlCol="0" anchor="ctr"/>
           <a:lstStyle/>
           <a:p>
-            <a:pPr indent="0" marL="0">
+            <a:pPr marL="0" indent="0">
               <a:buNone/>
             </a:pPr>
             <a:r>
@@ -5732,7 +5536,7 @@
           <a:bodyPr wrap="square" rtlCol="0" anchor="ctr"/>
           <a:lstStyle/>
           <a:p>
-            <a:pPr indent="0" marL="0">
+            <a:pPr marL="0" indent="0">
               <a:buNone/>
             </a:pPr>
             <a:r>
@@ -5791,7 +5595,7 @@
           <a:bodyPr wrap="square" rtlCol="0" anchor="ctr"/>
           <a:lstStyle/>
           <a:p>
-            <a:pPr indent="0" marL="0">
+            <a:pPr marL="0" indent="0">
               <a:buNone/>
             </a:pPr>
             <a:r>
@@ -5827,7 +5631,7 @@
           <a:bodyPr wrap="square" rtlCol="0" anchor="ctr"/>
           <a:lstStyle/>
           <a:p>
-            <a:pPr indent="0" marL="0">
+            <a:pPr marL="0" indent="0">
               <a:buNone/>
             </a:pPr>
             <a:r>
@@ -5886,7 +5690,7 @@
           <a:bodyPr wrap="square" rtlCol="0" anchor="ctr"/>
           <a:lstStyle/>
           <a:p>
-            <a:pPr indent="0" marL="0">
+            <a:pPr marL="0" indent="0">
               <a:buNone/>
             </a:pPr>
             <a:r>
@@ -5922,7 +5726,7 @@
           <a:bodyPr wrap="square" rtlCol="0" anchor="ctr"/>
           <a:lstStyle/>
           <a:p>
-            <a:pPr indent="0" marL="0">
+            <a:pPr marL="0" indent="0">
               <a:buNone/>
             </a:pPr>
             <a:r>
@@ -5981,7 +5785,7 @@
           <a:bodyPr wrap="square" rtlCol="0" anchor="ctr"/>
           <a:lstStyle/>
           <a:p>
-            <a:pPr indent="0" marL="0">
+            <a:pPr marL="0" indent="0">
               <a:buNone/>
             </a:pPr>
             <a:r>
@@ -6017,7 +5821,7 @@
           <a:bodyPr wrap="square" rtlCol="0" anchor="ctr"/>
           <a:lstStyle/>
           <a:p>
-            <a:pPr indent="0" marL="0">
+            <a:pPr marL="0" indent="0">
               <a:buNone/>
             </a:pPr>
             <a:r>
@@ -6053,7 +5857,7 @@
           <a:bodyPr wrap="square" rtlCol="0" anchor="ctr"/>
           <a:lstStyle/>
           <a:p>
-            <a:pPr algn="r" indent="0" marL="0">
+            <a:pPr marL="0" indent="0" algn="r">
               <a:buNone/>
             </a:pPr>
             <a:r>
@@ -6084,6 +5888,7 @@
         <a:solidFill>
           <a:srgbClr val="F8FAFC"/>
         </a:solidFill>
+        <a:effectLst/>
       </p:bgPr>
     </p:bg>
     <p:spTree>
@@ -6146,7 +5951,7 @@
           <a:bodyPr wrap="square" rtlCol="0" anchor="ctr"/>
           <a:lstStyle/>
           <a:p>
-            <a:pPr indent="0" marL="0">
+            <a:pPr marL="0" indent="0">
               <a:buNone/>
             </a:pPr>
             <a:r>
@@ -6185,7 +5990,7 @@
           <a:bodyPr wrap="square" rtlCol="0" anchor="ctr"/>
           <a:lstStyle/>
           <a:p>
-            <a:pPr indent="0" marL="0">
+            <a:pPr marL="0" indent="0">
               <a:buNone/>
             </a:pPr>
             <a:r>
@@ -6330,7 +6135,7 @@
           <a:bodyPr wrap="square" rtlCol="0" anchor="ctr"/>
           <a:lstStyle/>
           <a:p>
-            <a:pPr algn="ctr" indent="0" marL="0">
+            <a:pPr marL="0" indent="0" algn="ctr">
               <a:buNone/>
             </a:pPr>
             <a:r>
@@ -6366,7 +6171,7 @@
           <a:bodyPr wrap="square" rtlCol="0" anchor="ctr"/>
           <a:lstStyle/>
           <a:p>
-            <a:pPr algn="ctr" indent="0" marL="0">
+            <a:pPr marL="0" indent="0" algn="ctr">
               <a:buNone/>
             </a:pPr>
             <a:r>
@@ -6402,7 +6207,7 @@
           <a:bodyPr wrap="square" rtlCol="0" anchor="ctr"/>
           <a:lstStyle/>
           <a:p>
-            <a:pPr algn="r" indent="0" marL="0">
+            <a:pPr marL="0" indent="0" algn="r">
               <a:buNone/>
             </a:pPr>
             <a:r>
@@ -6426,7 +6231,7 @@
 </file>
 
 <file path=ppt/slides/slide9.xml><?xml version="1.0" encoding="utf-8"?>
-<p:sld xmlns:a="http://schemas.openxmlformats.org/drawingml/2006/main" xmlns:p="http://schemas.openxmlformats.org/presentationml/2006/main" xmlns:r="http://schemas.openxmlformats.org/officeDocument/2006/relationships">
+<p:sld xmlns:a="http://schemas.openxmlformats.org/drawingml/2006/main" xmlns:r="http://schemas.openxmlformats.org/officeDocument/2006/relationships" xmlns:p="http://schemas.openxmlformats.org/presentationml/2006/main">
   <p:cSld>
     <p:spTree>
       <p:nvGrpSpPr>
@@ -6434,7 +6239,14 @@
         <p:cNvGrpSpPr/>
         <p:nvPr/>
       </p:nvGrpSpPr>
-      <p:grpSpPr/>
+      <p:grpSpPr>
+        <a:xfrm>
+          <a:off x="0" y="0"/>
+          <a:ext cx="0" cy="0"/>
+          <a:chOff x="0" y="0"/>
+          <a:chExt cx="0" cy="0"/>
+        </a:xfrm>
+      </p:grpSpPr>
       <p:sp>
         <p:nvSpPr>
           <p:cNvPr id="2" name="TextBox 1"/>
@@ -6816,4 +6628,265 @@
     </a:ext>
   </a:extLst>
 </a:theme>
+</file>
+
+<file path=ppt/theme/theme2.xml><?xml version="1.0" encoding="utf-8"?>
+<a:theme xmlns:a="http://schemas.openxmlformats.org/drawingml/2006/main" name="Office Theme">
+  <a:themeElements>
+    <a:clrScheme name="Office">
+      <a:dk1>
+        <a:sysClr val="windowText" lastClr="000000"/>
+      </a:dk1>
+      <a:lt1>
+        <a:sysClr val="window" lastClr="FFFFFF"/>
+      </a:lt1>
+      <a:dk2>
+        <a:srgbClr val="44546A"/>
+      </a:dk2>
+      <a:lt2>
+        <a:srgbClr val="E7E6E6"/>
+      </a:lt2>
+      <a:accent1>
+        <a:srgbClr val="5B9BD5"/>
+      </a:accent1>
+      <a:accent2>
+        <a:srgbClr val="ED7D31"/>
+      </a:accent2>
+      <a:accent3>
+        <a:srgbClr val="A5A5A5"/>
+      </a:accent3>
+      <a:accent4>
+        <a:srgbClr val="FFC000"/>
+      </a:accent4>
+      <a:accent5>
+        <a:srgbClr val="4472C4"/>
+      </a:accent5>
+      <a:accent6>
+        <a:srgbClr val="70AD47"/>
+      </a:accent6>
+      <a:hlink>
+        <a:srgbClr val="0563C1"/>
+      </a:hlink>
+      <a:folHlink>
+        <a:srgbClr val="954F72"/>
+      </a:folHlink>
+    </a:clrScheme>
+    <a:fontScheme name="Office">
+      <a:majorFont>
+        <a:latin typeface="Calibri Light" panose="020F0302020204030204"/>
+        <a:ea typeface=""/>
+        <a:cs typeface=""/>
+        <a:font script="Jpan" typeface="ＭＳ Ｐゴシック"/>
+        <a:font script="Hang" typeface="맑은 고딕"/>
+        <a:font script="Hans" typeface="宋体"/>
+        <a:font script="Hant" typeface="新細明體"/>
+        <a:font script="Arab" typeface="Times New Roman"/>
+        <a:font script="Hebr" typeface="Times New Roman"/>
+        <a:font script="Thai" typeface="Angsana New"/>
+        <a:font script="Ethi" typeface="Nyala"/>
+        <a:font script="Beng" typeface="Vrinda"/>
+        <a:font script="Gujr" typeface="Shruti"/>
+        <a:font script="Khmr" typeface="MoolBoran"/>
+        <a:font script="Knda" typeface="Tunga"/>
+        <a:font script="Guru" typeface="Raavi"/>
+        <a:font script="Cans" typeface="Euphemia"/>
+        <a:font script="Cher" typeface="Plantagenet Cherokee"/>
+        <a:font script="Yiii" typeface="Microsoft Yi Baiti"/>
+        <a:font script="Tibt" typeface="Microsoft Himalaya"/>
+        <a:font script="Thaa" typeface="MV Boli"/>
+        <a:font script="Deva" typeface="Mangal"/>
+        <a:font script="Telu" typeface="Gautami"/>
+        <a:font script="Taml" typeface="Latha"/>
+        <a:font script="Syrc" typeface="Estrangelo Edessa"/>
+        <a:font script="Orya" typeface="Kalinga"/>
+        <a:font script="Mlym" typeface="Kartika"/>
+        <a:font script="Laoo" typeface="DokChampa"/>
+        <a:font script="Sinh" typeface="Iskoola Pota"/>
+        <a:font script="Mong" typeface="Mongolian Baiti"/>
+        <a:font script="Viet" typeface="Times New Roman"/>
+        <a:font script="Uigh" typeface="Microsoft Uighur"/>
+        <a:font script="Geor" typeface="Sylfaen"/>
+      </a:majorFont>
+      <a:minorFont>
+        <a:latin typeface="Calibri" panose="020F0502020204030204"/>
+        <a:ea typeface=""/>
+        <a:cs typeface=""/>
+        <a:font script="Jpan" typeface="ＭＳ Ｐゴシック"/>
+        <a:font script="Hang" typeface="맑은 고딕"/>
+        <a:font script="Hans" typeface="宋体"/>
+        <a:font script="Hant" typeface="新細明體"/>
+        <a:font script="Arab" typeface="Arial"/>
+        <a:font script="Hebr" typeface="Arial"/>
+        <a:font script="Thai" typeface="Cordia New"/>
+        <a:font script="Ethi" typeface="Nyala"/>
+        <a:font script="Beng" typeface="Vrinda"/>
+        <a:font script="Gujr" typeface="Shruti"/>
+        <a:font script="Khmr" typeface="DaunPenh"/>
+        <a:font script="Knda" typeface="Tunga"/>
+        <a:font script="Guru" typeface="Raavi"/>
+        <a:font script="Cans" typeface="Euphemia"/>
+        <a:font script="Cher" typeface="Plantagenet Cherokee"/>
+        <a:font script="Yiii" typeface="Microsoft Yi Baiti"/>
+        <a:font script="Tibt" typeface="Microsoft Himalaya"/>
+        <a:font script="Thaa" typeface="MV Boli"/>
+        <a:font script="Deva" typeface="Mangal"/>
+        <a:font script="Telu" typeface="Gautami"/>
+        <a:font script="Taml" typeface="Latha"/>
+        <a:font script="Syrc" typeface="Estrangelo Edessa"/>
+        <a:font script="Orya" typeface="Kalinga"/>
+        <a:font script="Mlym" typeface="Kartika"/>
+        <a:font script="Laoo" typeface="DokChampa"/>
+        <a:font script="Sinh" typeface="Iskoola Pota"/>
+        <a:font script="Mong" typeface="Mongolian Baiti"/>
+        <a:font script="Viet" typeface="Arial"/>
+        <a:font script="Uigh" typeface="Microsoft Uighur"/>
+        <a:font script="Geor" typeface="Sylfaen"/>
+      </a:minorFont>
+    </a:fontScheme>
+    <a:fmtScheme name="Office">
+      <a:fillStyleLst>
+        <a:solidFill>
+          <a:schemeClr val="phClr"/>
+        </a:solidFill>
+        <a:gradFill rotWithShape="1">
+          <a:gsLst>
+            <a:gs pos="0">
+              <a:schemeClr val="phClr">
+                <a:lumMod val="110000"/>
+                <a:satMod val="105000"/>
+                <a:tint val="67000"/>
+              </a:schemeClr>
+            </a:gs>
+            <a:gs pos="50000">
+              <a:schemeClr val="phClr">
+                <a:lumMod val="105000"/>
+                <a:satMod val="103000"/>
+                <a:tint val="73000"/>
+              </a:schemeClr>
+            </a:gs>
+            <a:gs pos="100000">
+              <a:schemeClr val="phClr">
+                <a:lumMod val="105000"/>
+                <a:satMod val="109000"/>
+                <a:tint val="81000"/>
+              </a:schemeClr>
+            </a:gs>
+          </a:gsLst>
+          <a:lin ang="5400000" scaled="0"/>
+        </a:gradFill>
+        <a:gradFill rotWithShape="1">
+          <a:gsLst>
+            <a:gs pos="0">
+              <a:schemeClr val="phClr">
+                <a:satMod val="103000"/>
+                <a:lumMod val="102000"/>
+                <a:tint val="94000"/>
+              </a:schemeClr>
+            </a:gs>
+            <a:gs pos="50000">
+              <a:schemeClr val="phClr">
+                <a:satMod val="110000"/>
+                <a:lumMod val="100000"/>
+                <a:shade val="100000"/>
+              </a:schemeClr>
+            </a:gs>
+            <a:gs pos="100000">
+              <a:schemeClr val="phClr">
+                <a:lumMod val="99000"/>
+                <a:satMod val="120000"/>
+                <a:shade val="78000"/>
+              </a:schemeClr>
+            </a:gs>
+          </a:gsLst>
+          <a:lin ang="5400000" scaled="0"/>
+        </a:gradFill>
+      </a:fillStyleLst>
+      <a:lnStyleLst>
+        <a:ln w="6350" cap="flat" cmpd="sng" algn="ctr">
+          <a:solidFill>
+            <a:schemeClr val="phClr"/>
+          </a:solidFill>
+          <a:prstDash val="solid"/>
+          <a:miter lim="800000"/>
+        </a:ln>
+        <a:ln w="12700" cap="flat" cmpd="sng" algn="ctr">
+          <a:solidFill>
+            <a:schemeClr val="phClr"/>
+          </a:solidFill>
+          <a:prstDash val="solid"/>
+          <a:miter lim="800000"/>
+        </a:ln>
+        <a:ln w="19050" cap="flat" cmpd="sng" algn="ctr">
+          <a:solidFill>
+            <a:schemeClr val="phClr"/>
+          </a:solidFill>
+          <a:prstDash val="solid"/>
+          <a:miter lim="800000"/>
+        </a:ln>
+      </a:lnStyleLst>
+      <a:effectStyleLst>
+        <a:effectStyle>
+          <a:effectLst/>
+        </a:effectStyle>
+        <a:effectStyle>
+          <a:effectLst/>
+        </a:effectStyle>
+        <a:effectStyle>
+          <a:effectLst>
+            <a:outerShdw blurRad="57150" dist="19050" dir="5400000" algn="ctr" rotWithShape="0">
+              <a:srgbClr val="000000">
+                <a:alpha val="63000"/>
+              </a:srgbClr>
+            </a:outerShdw>
+          </a:effectLst>
+        </a:effectStyle>
+      </a:effectStyleLst>
+      <a:bgFillStyleLst>
+        <a:solidFill>
+          <a:schemeClr val="phClr"/>
+        </a:solidFill>
+        <a:solidFill>
+          <a:schemeClr val="phClr">
+            <a:tint val="95000"/>
+            <a:satMod val="170000"/>
+          </a:schemeClr>
+        </a:solidFill>
+        <a:gradFill rotWithShape="1">
+          <a:gsLst>
+            <a:gs pos="0">
+              <a:schemeClr val="phClr">
+                <a:tint val="93000"/>
+                <a:satMod val="150000"/>
+                <a:shade val="98000"/>
+                <a:lumMod val="102000"/>
+              </a:schemeClr>
+            </a:gs>
+            <a:gs pos="50000">
+              <a:schemeClr val="phClr">
+                <a:tint val="98000"/>
+                <a:satMod val="130000"/>
+                <a:shade val="90000"/>
+                <a:lumMod val="103000"/>
+              </a:schemeClr>
+            </a:gs>
+            <a:gs pos="100000">
+              <a:schemeClr val="phClr">
+                <a:shade val="63000"/>
+                <a:satMod val="120000"/>
+              </a:schemeClr>
+            </a:gs>
+          </a:gsLst>
+          <a:lin ang="5400000" scaled="0"/>
+        </a:gradFill>
+      </a:bgFillStyleLst>
+    </a:fmtScheme>
+  </a:themeElements>
+  <a:objectDefaults/>
+  <a:extraClrSchemeLst/>
+  <a:extLst>
+    <a:ext uri="{05A4C25C-085E-4340-85A3-A5531E510DB2}">
+      <thm15:themeFamily xmlns:thm15="http://schemas.microsoft.com/office/thememl/2012/main" name="Office Theme" id="{62F939B6-93AF-4DB8-9C6B-D6C7DFDC589F}" vid="{4A3C46E8-61CC-4603-A589-7422A47A8E4A}"/>
+    </a:ext>
+  </a:extLst>
+</a:theme>
 </file>
</xml_diff>